<commit_message>
Update the CTA presentation: persona dashboards slide
Slide 5 now frames the environment for two audiences (executive outcomes and
risk, engineer operations) instead of the TLS DataSource; talk tracks on the
customer story are in the first person.
</commit_message>
<xml_diff>
--- a/Collateral/CTA_Presentation_Dennis_Katumalla_DRAFT.pptx
+++ b/Collateral/CTA_Presentation_Dennis_Katumalla_DRAFT.pptx
@@ -113,24 +113,24 @@
   <p:extLst>
     <p:ext uri="{521415D9-36F7-43E2-AB2F-B90AF26B5E84}">
       <p14:sectionLst xmlns:p14="http://schemas.microsoft.com/office/powerpoint/2010/main">
-        <p14:section name="Who I am" id="{4b4c35bd-fd2f-7812-0056-f428c8fb8f8e}">
+        <p14:section name="Who I am" id="{176917e3-545e-6848-45d4-d7d2fd6125e7}">
           <p14:sldIdLst>
             <p14:sldId id="256"/>
           </p14:sldIdLst>
         </p14:section>
-        <p14:section name="Customer experience" id="{ff9fac0c-6924-7ca2-be1e-1f59bfd2395e}">
+        <p14:section name="Customer experience" id="{9909e666-9c93-f69e-b82a-673999b0c186}">
           <p14:sldIdLst>
             <p14:sldId id="257"/>
             <p14:sldId id="258"/>
           </p14:sldIdLst>
         </p14:section>
-        <p14:section name="Technical experience" id="{116fa9c1-7e0c-23fc-00ac-5aedefb7f668}">
+        <p14:section name="Technical experience" id="{76e2dfe8-c4e4-a56f-842f-08e33d6510b5}">
           <p14:sldIdLst>
             <p14:sldId id="259"/>
             <p14:sldId id="260"/>
           </p14:sldIdLst>
         </p14:section>
-        <p14:section name="Why me, and the first 90 days" id="{8cef7a2e-ee86-c00b-95d6-46f887910d09}">
+        <p14:section name="Why me, and the first 90 days" id="{3e951956-208d-0587-8b28-ebd401bd6888}">
           <p14:sldIdLst>
             <p14:sldId id="261"/>
             <p14:sldId id="262"/>
@@ -634,7 +634,7 @@
               <a:t>About 2 minutes for this slide and the next together.
 "The engagement I want to walk you through ran for over two years at a Fortune 500 electric utility with millions of customers across several states. They were running Dynatrace. The business wanted to consolidate tools and lower cost, get broader coverage across network, infrastructure and legacy systems, and above all keep outage reporting reliable during hurricane season, when customers depend on it most.
 I was the technical lead from evaluation through implementation. [Team and what I owned.]
-Three kinds of risk. Technical: 5,000+ agents to migrate across application, infrastructure and network. Political: we were displacing a tool that teams had built their workflows around. [Who resisted, and how I won them over.] Timing: change freezes during hurricane season limit when you can cut anything over."</a:t>
+Three kinds of risk. Technical: 5,000+ agents to migrate across application, infrastructure and network. Political: I was leading the displacement of a tool that teams had built their workflows around. [Who resisted, and how I won them over.] Timing: change freezes during hurricane season limit when you can cut anything over."</a:t>
             </a:r>
             <a:endParaRPr lang="en-US" dirty="0"/>
           </a:p>
@@ -723,7 +723,7 @@
             <a:r>
               <a:rPr lang="en-US" dirty="0"/>
               <a:t>About 2 minutes.
-"We didn't do a big-bang swap. We migrated in waves, ran both tools in parallel so nobody lost visibility, and only cut a wave over once it reached parity on the alerts and dashboards that mattered. [The hardest technical issue, and how I fixed it.] [A moment something broke, and how I restored it.] The whole time I was also covering [other accounts]; I kept them going by [method].
+"I ruled out a big-bang swap. I planned the migration in waves, ran both tools in parallel so nobody lost visibility, and I only signed off a wave once it reached parity on the alerts and dashboards that mattered. [The hardest technical issue, and how I fixed it.] [A moment something broke, and how I restored it.] The whole time I was also covering [other accounts]; I kept them going by [method].
 The result was [tools retired, savings, MTTR or incident change], and the account [renewed / expanded]."
 Then: "Happy to go deeper on any part of that."</a:t>
             </a:r>
@@ -813,8 +813,8 @@
           <a:p>
             <a:r>
               <a:rPr lang="en-US" dirty="0"/>
-              <a:t>About 2 minutes. Left to right: what we monitored, how it was collected, where it was correlated, who acted on it.
-"Customer-facing apps were the priority because outage reporting is what customers see during a storm. DX APM covered those apps, UIM covered the data centers, NetOps did fault isolation across the network, and we added Kubernetes and AWS. Everything fed DX Operational Observability for topology, correlation and service views, then into the NOC, ITSM and executive dashboards."
+              <a:t>About 2 minutes. Left to right: what I scoped, how it was collected, where it was correlated, who acted on it.
+"I designed this target architecture. I prioritised the customer-facing apps, because outage reporting is what customers see during a storm. I put DX APM on those apps, UIM across the data centers and NetOps on fault isolation across the network, and I extended coverage to Kubernetes and AWS. I fed everything into DX Operational Observability for topology, correlation and service views, then into the NOC, ITSM and executive dashboards."
 Bottom row: "In LogicMonitor terms, hubs and robots become Collector groups, probes become LogicModules driven by AppliesTo, NetOps fault isolation becomes topology and alert dependencies, and alarm correlation becomes Edwin AI. That's the mapping I'd use for a customer moving off UIM or DX."
 Trade-offs, if asked: agent vs agentless in restricted zones, polling intervals, SNMPv3 vs v2c, data retention.</a:t>
             </a:r>
@@ -904,18 +904,10 @@
           <a:p>
             <a:r>
               <a:rPr lang="en-US" dirty="0"/>
-              <a:t>About 2 minutes.
-Left: "Before I had a portal, I built a real LogicModule: a DataSource that monitors TLS certificate expiry and trust on any host and port. If an endpoint is down, it still reports cleanly, so you get one alert that names the real problem instead of missing data. And it runs on both Groovy 2 and Groovy 4 collectors, because collectors in the field aren't all on the same version."
-Right: "Then I built something closer to the customer story: a small outage-reporting service for a fictional utility. Eight steps, and I'll show you each one in the demo.
-1. Deploy: the VM and the app are built from code, with the AWS CLI and a first-boot script.
-2. Collect: a Collector on the VM, plus a read-only AWS integration, so I can still see the VM if the Collector can't.
-3. Discover: I set properties on the resource, and AppliesTo brings in the SNMP, SSH and JMX modules automatically.
-4. Instrument: a Groovy DataSource that reads the app's health endpoint, with technical and business KPIs.
-5. Test outside-in: an LM Uptime check loads the page and files a test report, the way a customer would.
-6. Correlate: the app's logs land in LM Logs on the same resource.
-7. Act: an alert rule, an escalation chain, and a dashboard with the business view first.
-8. Prove it: I break it on purpose, and each fault raises one alert that names its cause."
-Then: "Let me show you."</a:t>
+              <a:t>About 90 seconds, then switch to the demo.
+"I built a small version of the service from my customer story, a utility's outage-reporting site, from a blank AWS account, and I monitored it in LogicMonitor end to end. I deployed the VM and app from code, installed a Collector, connected AWS with a read-only role, and wrote a Groovy DataSource that turns the app's health into technical and business metrics.
+The same environment serves two audiences, so I built two dashboards. An executive asks about outcomes and risk: can customers report an outage, how many are without power, and how long are they waiting for an estimate. An engineer asks what's broken, where, and who has the ticket: latency, errors, the JVM, the OS, the logs, and alerts routed to on-call with one alert per cause.
+Let me show you, starting with the executive view."</a:t>
             </a:r>
             <a:endParaRPr lang="en-US" dirty="0"/>
           </a:p>
@@ -3419,7 +3411,7 @@
                   <a:schemeClr val="accent3"/>
                 </a:solidFill>
               </a:rPr>
-              <a:t>[What we chose not to migrate]</a:t>
+              <a:t>[What I chose not to migrate]</a:t>
             </a:r>
             <a:endParaRPr lang="en-US" sz="1600" dirty="0"/>
           </a:p>
@@ -5215,7 +5207,7 @@
                   <a:schemeClr val="accent2"/>
                 </a:solidFill>
               </a:rPr>
-              <a:t>TECHNICAL EXPERIENCE · HANDS-ON WITH LOGICMONITOR</a:t>
+              <a:t>TECHNICAL EXPERIENCE · WHAT I BUILT IN LOGICMONITOR</a:t>
             </a:r>
             <a:endParaRPr lang="en-US" sz="1200" dirty="0"/>
           </a:p>
@@ -5253,7 +5245,7 @@
                   <a:schemeClr val="tx1"/>
                 </a:solidFill>
               </a:rPr>
-              <a:t>I learn a platform by building on it</a:t>
+              <a:t>One environment, two audiences</a:t>
             </a:r>
             <a:endParaRPr lang="en-US" sz="3200" dirty="0"/>
           </a:p>
@@ -5261,18 +5253,204 @@
       </p:sp>
       <p:sp>
         <p:nvSpPr>
-          <p:cNvPr id="5" name="TLS card"/>
+          <p:cNvPr id="5" name="EXECUTIVE VIEW · OUTCOMES AND RISK card"/>
           <p:cNvSpPr/>
           <p:nvPr/>
         </p:nvSpPr>
         <p:spPr>
           <a:xfrm>
             <a:off x="812902" y="2011680"/>
-            <a:ext cx="3566160" cy="3931920"/>
+            <a:ext cx="5145786" cy="3246120"/>
           </a:xfrm>
           <a:prstGeom prst="roundRect">
             <a:avLst>
-              <a:gd name="adj" fmla="val 3077"/>
+              <a:gd name="adj" fmla="val 3380"/>
+            </a:avLst>
+          </a:prstGeom>
+          <a:solidFill>
+            <a:schemeClr val="tx1"/>
+          </a:solidFill>
+          <a:ln/>
+        </p:spPr>
+      </p:sp>
+      <p:sp>
+        <p:nvSpPr>
+          <p:cNvPr id="6" name="EXECUTIVE VIEW · OUTCOMES AND RISK"/>
+          <p:cNvSpPr txBox="1"/>
+          <p:nvPr/>
+        </p:nvSpPr>
+        <p:spPr>
+          <a:xfrm>
+            <a:off x="1105510" y="2267712"/>
+            <a:ext cx="4560570" cy="2377440"/>
+          </a:xfrm>
+          <a:prstGeom prst="rect">
+            <a:avLst/>
+          </a:prstGeom>
+          <a:noFill/>
+          <a:ln/>
+        </p:spPr>
+        <p:txBody>
+          <a:bodyPr wrap="square" lIns="0" tIns="0" rIns="0" bIns="0" rtlCol="0" anchor="t"/>
+          <a:lstStyle/>
+          <a:p>
+            <a:pPr indent="0" marL="0">
+              <a:spcAft>
+                <a:spcPts val="600"/>
+              </a:spcAft>
+              <a:buNone/>
+            </a:pPr>
+            <a:r>
+              <a:rPr lang="en-US" sz="1200" b="1" spc="200" kern="0" dirty="0">
+                <a:solidFill>
+                  <a:schemeClr val="accent1"/>
+                </a:solidFill>
+              </a:rPr>
+              <a:t>EXECUTIVE VIEW · OUTCOMES AND RISK</a:t>
+            </a:r>
+            <a:endParaRPr lang="en-US" sz="1200" dirty="0"/>
+          </a:p>
+          <a:p>
+            <a:pPr indent="0" marL="0">
+              <a:spcAft>
+                <a:spcPts val="1000"/>
+              </a:spcAft>
+              <a:buNone/>
+            </a:pPr>
+            <a:r>
+              <a:rPr lang="en-US" sz="1800" b="1" dirty="0">
+                <a:solidFill>
+                  <a:schemeClr val="bg1"/>
+                </a:solidFill>
+              </a:rPr>
+              <a:t>Can customers report outages, and how long are they waiting?</a:t>
+            </a:r>
+            <a:endParaRPr lang="en-US" sz="1200" dirty="0"/>
+          </a:p>
+          <a:p>
+            <a:pPr marL="177800" indent="-177800">
+              <a:spcAft>
+                <a:spcPts val="600"/>
+              </a:spcAft>
+              <a:buSzPct val="100000"/>
+              <a:buChar char="•"/>
+            </a:pPr>
+            <a:r>
+              <a:rPr lang="en-US" sz="1400" dirty="0">
+                <a:solidFill>
+                  <a:schemeClr val="accent4"/>
+                </a:solidFill>
+              </a:rPr>
+              <a:t>Customer journey available from 5 locations worldwide</a:t>
+            </a:r>
+            <a:endParaRPr lang="en-US" sz="1200" dirty="0"/>
+          </a:p>
+          <a:p>
+            <a:pPr marL="177800" indent="-177800">
+              <a:spcAft>
+                <a:spcPts val="600"/>
+              </a:spcAft>
+              <a:buSzPct val="100000"/>
+              <a:buChar char="•"/>
+            </a:pPr>
+            <a:r>
+              <a:rPr lang="en-US" sz="1400" dirty="0">
+                <a:solidFill>
+                  <a:schemeClr val="accent4"/>
+                </a:solidFill>
+              </a:rPr>
+              <a:t>Customers without power and open outages</a:t>
+            </a:r>
+            <a:endParaRPr lang="en-US" sz="1200" dirty="0"/>
+          </a:p>
+          <a:p>
+            <a:pPr marL="177800" indent="-177800">
+              <a:spcAft>
+                <a:spcPts val="600"/>
+              </a:spcAft>
+              <a:buSzPct val="100000"/>
+              <a:buChar char="•"/>
+            </a:pPr>
+            <a:r>
+              <a:rPr lang="en-US" sz="1400" dirty="0">
+                <a:solidFill>
+                  <a:schemeClr val="accent4"/>
+                </a:solidFill>
+              </a:rPr>
+              <a:t>Customers waiting for an estimate: the storm risk</a:t>
+            </a:r>
+            <a:endParaRPr lang="en-US" sz="1200" dirty="0"/>
+          </a:p>
+          <a:p>
+            <a:pPr marL="177800" indent="-177800">
+              <a:spcAft>
+                <a:spcPts val="600"/>
+              </a:spcAft>
+              <a:buSzPct val="100000"/>
+              <a:buChar char="•"/>
+            </a:pPr>
+            <a:r>
+              <a:rPr lang="en-US" sz="1400" dirty="0">
+                <a:solidFill>
+                  <a:schemeClr val="accent4"/>
+                </a:solidFill>
+              </a:rPr>
+              <a:t>Active alerts by severity</a:t>
+            </a:r>
+            <a:endParaRPr lang="en-US" sz="1200" dirty="0"/>
+          </a:p>
+        </p:txBody>
+      </p:sp>
+      <p:sp>
+        <p:nvSpPr>
+          <p:cNvPr id="7" name="EXECUTIVE VIEW · OUTCOMES AND RISK dashboard"/>
+          <p:cNvSpPr txBox="1"/>
+          <p:nvPr/>
+        </p:nvSpPr>
+        <p:spPr>
+          <a:xfrm>
+            <a:off x="1105510" y="4709160"/>
+            <a:ext cx="4560570" cy="365760"/>
+          </a:xfrm>
+          <a:prstGeom prst="rect">
+            <a:avLst/>
+          </a:prstGeom>
+          <a:noFill/>
+          <a:ln/>
+        </p:spPr>
+        <p:txBody>
+          <a:bodyPr wrap="square" lIns="0" tIns="0" rIns="0" bIns="0" rtlCol="0" anchor="b"/>
+          <a:lstStyle/>
+          <a:p>
+            <a:pPr indent="0" marL="0">
+              <a:buNone/>
+            </a:pPr>
+            <a:r>
+              <a:rPr lang="en-US" sz="1300" dirty="0">
+                <a:solidFill>
+                  <a:schemeClr val="accent1"/>
+                </a:solidFill>
+              </a:rPr>
+              <a:t>Live dashboard: Outage Reporter · Executive</a:t>
+            </a:r>
+            <a:endParaRPr lang="en-US" sz="1300" dirty="0"/>
+          </a:p>
+        </p:txBody>
+      </p:sp>
+      <p:sp>
+        <p:nvSpPr>
+          <p:cNvPr id="8" name="ENGINEER VIEW · OPERATIONS card"/>
+          <p:cNvSpPr/>
+          <p:nvPr/>
+        </p:nvSpPr>
+        <p:spPr>
+          <a:xfrm>
+            <a:off x="6233008" y="2011680"/>
+            <a:ext cx="5145786" cy="3246120"/>
+          </a:xfrm>
+          <a:prstGeom prst="roundRect">
+            <a:avLst>
+              <a:gd name="adj" fmla="val 3380"/>
             </a:avLst>
           </a:prstGeom>
           <a:solidFill>
@@ -5290,14 +5468,14 @@
       </p:sp>
       <p:sp>
         <p:nvSpPr>
-          <p:cNvPr id="6" name="TLS DataSource"/>
+          <p:cNvPr id="9" name="ENGINEER VIEW · OPERATIONS"/>
           <p:cNvSpPr txBox="1"/>
           <p:nvPr/>
         </p:nvSpPr>
         <p:spPr>
           <a:xfrm>
-            <a:off x="1068934" y="2267712"/>
-            <a:ext cx="3054096" cy="2834640"/>
+            <a:off x="6525616" y="2267712"/>
+            <a:ext cx="4560570" cy="2377440"/>
           </a:xfrm>
           <a:prstGeom prst="rect">
             <a:avLst/>
@@ -5318,10 +5496,10 @@
             <a:r>
               <a:rPr lang="en-US" sz="1200" b="1" spc="200" kern="0" dirty="0">
                 <a:solidFill>
-                  <a:schemeClr val="accent5"/>
-                </a:solidFill>
-              </a:rPr>
-              <a:t>BEFORE PORTAL ACCESS</a:t>
+                  <a:schemeClr val="accent2"/>
+                </a:solidFill>
+              </a:rPr>
+              <a:t>ENGINEER VIEW · OPERATIONS</a:t>
             </a:r>
             <a:endParaRPr lang="en-US" sz="1200" dirty="0"/>
           </a:p>
@@ -5338,7 +5516,7 @@
                   <a:schemeClr val="tx1"/>
                 </a:solidFill>
               </a:rPr>
-              <a:t>TLS certificate expiry DataSource</a:t>
+              <a:t>What is broken, where, and who has the ticket?</a:t>
             </a:r>
             <a:endParaRPr lang="en-US" sz="1200" dirty="0"/>
           </a:p>
@@ -5351,12 +5529,12 @@
               <a:buChar char="•"/>
             </a:pPr>
             <a:r>
-              <a:rPr lang="en-US" sz="1300" dirty="0">
+              <a:rPr lang="en-US" sz="1400" dirty="0">
                 <a:solidFill>
                   <a:schemeClr val="tx2"/>
                 </a:solidFill>
               </a:rPr>
-              <a:t>Groovy with Active Discovery: one property lists the endpoints</a:t>
+              <a:t>Latency, error rate and data-store health</a:t>
             </a:r>
             <a:endParaRPr lang="en-US" sz="1200" dirty="0"/>
           </a:p>
@@ -5369,12 +5547,12 @@
               <a:buChar char="•"/>
             </a:pPr>
             <a:r>
-              <a:rPr lang="en-US" sz="1300" dirty="0">
+              <a:rPr lang="en-US" sz="1400" dirty="0">
                 <a:solidFill>
                   <a:schemeClr val="tx2"/>
                 </a:solidFill>
               </a:rPr>
-              <a:t>A dead endpoint raises one clear alert, not missing data</a:t>
+              <a:t>JVM heap and GC, CPU, memory, disk</a:t>
             </a:r>
             <a:endParaRPr lang="en-US" sz="1200" dirty="0"/>
           </a:p>
@@ -5387,158 +5565,146 @@
               <a:buChar char="•"/>
             </a:pPr>
             <a:r>
-              <a:rPr lang="en-US" sz="1300" dirty="0">
+              <a:rPr lang="en-US" sz="1400" dirty="0">
                 <a:solidFill>
                   <a:schemeClr val="tx2"/>
                 </a:solidFill>
               </a:rPr>
-              <a:t>Runs on Groovy 2 and 4; offline simulator and tests</a:t>
+              <a:t>App logs on the same resource as the metrics</a:t>
             </a:r>
             <a:endParaRPr lang="en-US" sz="1200" dirty="0"/>
           </a:p>
-        </p:txBody>
-      </p:sp>
-      <p:sp>
-        <p:nvSpPr>
-          <p:cNvPr id="7" name="TLS why"/>
-          <p:cNvSpPr txBox="1"/>
-          <p:nvPr/>
-        </p:nvSpPr>
-        <p:spPr>
-          <a:xfrm>
-            <a:off x="1068934" y="5166360"/>
-            <a:ext cx="3054096" cy="548640"/>
-          </a:xfrm>
-          <a:prstGeom prst="rect">
-            <a:avLst/>
-          </a:prstGeom>
-          <a:noFill/>
-          <a:ln/>
-        </p:spPr>
-        <p:txBody>
-          <a:bodyPr wrap="square" lIns="0" tIns="0" rIns="0" bIns="0" rtlCol="0" anchor="b"/>
-          <a:lstStyle/>
-          <a:p>
-            <a:pPr indent="0" marL="0">
-              <a:buNone/>
-            </a:pPr>
-            <a:r>
-              <a:rPr lang="en-US" sz="1300" dirty="0">
-                <a:solidFill>
-                  <a:schemeClr val="accent2"/>
-                </a:solidFill>
-              </a:rPr>
-              <a:t>Why it matters: certificate lifetimes drop to 47 days by 2029</a:t>
-            </a:r>
-            <a:endParaRPr lang="en-US" sz="1300" dirty="0"/>
-          </a:p>
-        </p:txBody>
-      </p:sp>
-      <p:sp>
-        <p:nvSpPr>
-          <p:cNvPr id="8" name="Build steps card"/>
-          <p:cNvSpPr/>
-          <p:nvPr/>
-        </p:nvSpPr>
-        <p:spPr>
-          <a:xfrm>
-            <a:off x="4653382" y="2011680"/>
-            <a:ext cx="6725412" cy="3931920"/>
-          </a:xfrm>
-          <a:prstGeom prst="roundRect">
-            <a:avLst>
-              <a:gd name="adj" fmla="val 2791"/>
-            </a:avLst>
-          </a:prstGeom>
-          <a:solidFill>
-            <a:schemeClr val="tx1"/>
-          </a:solidFill>
-          <a:ln/>
-        </p:spPr>
-      </p:sp>
-      <p:sp>
-        <p:nvSpPr>
-          <p:cNvPr id="9" name="Build steps heading"/>
-          <p:cNvSpPr txBox="1"/>
-          <p:nvPr/>
-        </p:nvSpPr>
-        <p:spPr>
-          <a:xfrm>
-            <a:off x="4927702" y="2267712"/>
-            <a:ext cx="6176772" cy="777240"/>
-          </a:xfrm>
-          <a:prstGeom prst="rect">
-            <a:avLst/>
-          </a:prstGeom>
-          <a:noFill/>
-          <a:ln/>
-        </p:spPr>
-        <p:txBody>
-          <a:bodyPr wrap="square" lIns="0" tIns="0" rIns="0" bIns="0" rtlCol="0" anchor="t"/>
-          <a:lstStyle/>
-          <a:p>
-            <a:pPr indent="0" marL="0">
+          <a:p>
+            <a:pPr marL="177800" indent="-177800">
               <a:spcAft>
                 <a:spcPts val="600"/>
               </a:spcAft>
+              <a:buSzPct val="100000"/>
+              <a:buChar char="•"/>
+            </a:pPr>
+            <a:r>
+              <a:rPr lang="en-US" sz="1400" dirty="0">
+                <a:solidFill>
+                  <a:schemeClr val="tx2"/>
+                </a:solidFill>
+              </a:rPr>
+              <a:t>Alerts routed to on-call, one per cause</a:t>
+            </a:r>
+            <a:endParaRPr lang="en-US" sz="1200" dirty="0"/>
+          </a:p>
+        </p:txBody>
+      </p:sp>
+      <p:sp>
+        <p:nvSpPr>
+          <p:cNvPr id="10" name="ENGINEER VIEW · OPERATIONS dashboard"/>
+          <p:cNvSpPr txBox="1"/>
+          <p:nvPr/>
+        </p:nvSpPr>
+        <p:spPr>
+          <a:xfrm>
+            <a:off x="6525616" y="4709160"/>
+            <a:ext cx="4560570" cy="365760"/>
+          </a:xfrm>
+          <a:prstGeom prst="rect">
+            <a:avLst/>
+          </a:prstGeom>
+          <a:noFill/>
+          <a:ln/>
+        </p:spPr>
+        <p:txBody>
+          <a:bodyPr wrap="square" lIns="0" tIns="0" rIns="0" bIns="0" rtlCol="0" anchor="b"/>
+          <a:lstStyle/>
+          <a:p>
+            <a:pPr indent="0" marL="0">
+              <a:buNone/>
+            </a:pPr>
+            <a:r>
+              <a:rPr lang="en-US" sz="1300" dirty="0">
+                <a:solidFill>
+                  <a:schemeClr val="accent2"/>
+                </a:solidFill>
+              </a:rPr>
+              <a:t>Live dashboard: Outage Reporter · Engineer</a:t>
+            </a:r>
+            <a:endParaRPr lang="en-US" sz="1300" dirty="0"/>
+          </a:p>
+        </p:txBody>
+      </p:sp>
+      <p:sp>
+        <p:nvSpPr>
+          <p:cNvPr id="11" name="Build strip"/>
+          <p:cNvSpPr/>
+          <p:nvPr/>
+        </p:nvSpPr>
+        <p:spPr>
+          <a:xfrm>
+            <a:off x="812902" y="5486400"/>
+            <a:ext cx="10565892" cy="658368"/>
+          </a:xfrm>
+          <a:prstGeom prst="roundRect">
+            <a:avLst>
+              <a:gd name="adj" fmla="val 16667"/>
+            </a:avLst>
+          </a:prstGeom>
+          <a:solidFill>
+            <a:schemeClr val="bg1"/>
+          </a:solidFill>
+          <a:ln w="9525">
+            <a:solidFill>
+              <a:schemeClr val="accent5">
+                <a:alpha val="35000"/>
+              </a:schemeClr>
+            </a:solidFill>
+            <a:prstDash val="solid"/>
+          </a:ln>
+        </p:spPr>
+      </p:sp>
+      <p:sp>
+        <p:nvSpPr>
+          <p:cNvPr id="12" name="Build strip label"/>
+          <p:cNvSpPr txBox="1"/>
+          <p:nvPr/>
+        </p:nvSpPr>
+        <p:spPr>
+          <a:xfrm>
+            <a:off x="1087222" y="5486400"/>
+            <a:ext cx="3566160" cy="658368"/>
+          </a:xfrm>
+          <a:prstGeom prst="rect">
+            <a:avLst/>
+          </a:prstGeom>
+          <a:noFill/>
+          <a:ln/>
+        </p:spPr>
+        <p:txBody>
+          <a:bodyPr wrap="square" lIns="0" tIns="0" rIns="0" bIns="0" rtlCol="0" anchor="ctr"/>
+          <a:lstStyle/>
+          <a:p>
+            <a:pPr indent="0" marL="0">
               <a:buNone/>
             </a:pPr>
             <a:r>
               <a:rPr lang="en-US" sz="1200" b="1" spc="200" kern="0" dirty="0">
                 <a:solidFill>
-                  <a:schemeClr val="accent1"/>
-                </a:solidFill>
-              </a:rPr>
-              <a:t>THE LIVE DEMO · HOW I BUILT IT</a:t>
+                  <a:schemeClr val="accent2"/>
+                </a:solidFill>
+              </a:rPr>
+              <a:t>BUILT FROM A BLANK AWS ACCOUNT</a:t>
             </a:r>
             <a:endParaRPr lang="en-US" sz="1200" dirty="0"/>
           </a:p>
-          <a:p>
-            <a:pPr indent="0" marL="0">
-              <a:buNone/>
-            </a:pPr>
-            <a:r>
-              <a:rPr lang="en-US" sz="1800" b="1" dirty="0">
-                <a:solidFill>
-                  <a:schemeClr val="bg1"/>
-                </a:solidFill>
-              </a:rPr>
-              <a:t>From a blank AWS account to a monitored utility service</a:t>
-            </a:r>
-            <a:endParaRPr lang="en-US" sz="1200" dirty="0"/>
-          </a:p>
-        </p:txBody>
-      </p:sp>
-      <p:sp>
-        <p:nvSpPr>
-          <p:cNvPr id="10" name="Step 1 badge"/>
-          <p:cNvSpPr/>
-          <p:nvPr/>
-        </p:nvSpPr>
-        <p:spPr>
-          <a:xfrm>
-            <a:off x="4927702" y="3218688"/>
-            <a:ext cx="310896" cy="310896"/>
-          </a:xfrm>
-          <a:prstGeom prst="ellipse">
-            <a:avLst/>
-          </a:prstGeom>
-          <a:solidFill>
-            <a:schemeClr val="accent1"/>
-          </a:solidFill>
-          <a:ln/>
-        </p:spPr>
-      </p:sp>
-      <p:sp>
-        <p:nvSpPr>
-          <p:cNvPr id="11" name="Step 1 number"/>
+        </p:txBody>
+      </p:sp>
+      <p:sp>
+        <p:nvSpPr>
+          <p:cNvPr id="13" name="Build strip"/>
           <p:cNvSpPr txBox="1"/>
           <p:nvPr/>
         </p:nvSpPr>
         <p:spPr>
           <a:xfrm>
-            <a:off x="4927702" y="3218688"/>
-            <a:ext cx="310896" cy="310896"/>
+            <a:off x="4744822" y="5486400"/>
+            <a:ext cx="6359652" cy="658368"/>
           </a:xfrm>
           <a:prstGeom prst="rect">
             <a:avLst/>
@@ -5550,784 +5716,16 @@
           <a:bodyPr wrap="square" lIns="0" tIns="0" rIns="0" bIns="0" rtlCol="0" anchor="ctr"/>
           <a:lstStyle/>
           <a:p>
-            <a:pPr algn="ctr" indent="0" marL="0">
-              <a:buNone/>
-            </a:pPr>
-            <a:r>
-              <a:rPr lang="en-US" sz="1200" b="1" dirty="0">
-                <a:solidFill>
-                  <a:schemeClr val="tx1"/>
-                </a:solidFill>
-              </a:rPr>
-              <a:t>1</a:t>
-            </a:r>
-            <a:endParaRPr lang="en-US" sz="1200" dirty="0"/>
-          </a:p>
-        </p:txBody>
-      </p:sp>
-      <p:sp>
-        <p:nvSpPr>
-          <p:cNvPr id="12" name="Step 1"/>
-          <p:cNvSpPr txBox="1"/>
-          <p:nvPr/>
-        </p:nvSpPr>
-        <p:spPr>
-          <a:xfrm>
-            <a:off x="5348326" y="3200400"/>
-            <a:ext cx="2530602" cy="585216"/>
-          </a:xfrm>
-          <a:prstGeom prst="rect">
-            <a:avLst/>
-          </a:prstGeom>
-          <a:noFill/>
-          <a:ln/>
-        </p:spPr>
-        <p:txBody>
-          <a:bodyPr wrap="square" lIns="0" tIns="0" rIns="0" bIns="0" rtlCol="0" anchor="t"/>
-          <a:lstStyle/>
-          <a:p>
-            <a:pPr indent="0" marL="0">
-              <a:buNone/>
-            </a:pPr>
-            <a:r>
-              <a:rPr lang="en-US" sz="1300" b="1" dirty="0">
-                <a:solidFill>
-                  <a:schemeClr val="bg1"/>
-                </a:solidFill>
-              </a:rPr>
-              <a:t>Deploy</a:t>
-            </a:r>
             <a:pPr indent="0" marL="0">
               <a:buNone/>
             </a:pPr>
             <a:r>
               <a:rPr lang="en-US" sz="1300" dirty="0">
                 <a:solidFill>
-                  <a:schemeClr val="accent4"/>
-                </a:solidFill>
-              </a:rPr>
-              <a:t> the VM and app from code</a:t>
-            </a:r>
-            <a:endParaRPr lang="en-US" sz="1300" dirty="0"/>
-          </a:p>
-        </p:txBody>
-      </p:sp>
-      <p:sp>
-        <p:nvSpPr>
-          <p:cNvPr id="13" name="Step 2 badge"/>
-          <p:cNvSpPr/>
-          <p:nvPr/>
-        </p:nvSpPr>
-        <p:spPr>
-          <a:xfrm>
-            <a:off x="4927702" y="3877056"/>
-            <a:ext cx="310896" cy="310896"/>
-          </a:xfrm>
-          <a:prstGeom prst="ellipse">
-            <a:avLst/>
-          </a:prstGeom>
-          <a:solidFill>
-            <a:schemeClr val="accent1"/>
-          </a:solidFill>
-          <a:ln/>
-        </p:spPr>
-      </p:sp>
-      <p:sp>
-        <p:nvSpPr>
-          <p:cNvPr id="14" name="Step 2 number"/>
-          <p:cNvSpPr txBox="1"/>
-          <p:nvPr/>
-        </p:nvSpPr>
-        <p:spPr>
-          <a:xfrm>
-            <a:off x="4927702" y="3877056"/>
-            <a:ext cx="310896" cy="310896"/>
-          </a:xfrm>
-          <a:prstGeom prst="rect">
-            <a:avLst/>
-          </a:prstGeom>
-          <a:noFill/>
-          <a:ln/>
-        </p:spPr>
-        <p:txBody>
-          <a:bodyPr wrap="square" lIns="0" tIns="0" rIns="0" bIns="0" rtlCol="0" anchor="ctr"/>
-          <a:lstStyle/>
-          <a:p>
-            <a:pPr algn="ctr" indent="0" marL="0">
-              <a:buNone/>
-            </a:pPr>
-            <a:r>
-              <a:rPr lang="en-US" sz="1200" b="1" dirty="0">
-                <a:solidFill>
-                  <a:schemeClr val="tx1"/>
-                </a:solidFill>
-              </a:rPr>
-              <a:t>2</a:t>
-            </a:r>
-            <a:endParaRPr lang="en-US" sz="1200" dirty="0"/>
-          </a:p>
-        </p:txBody>
-      </p:sp>
-      <p:sp>
-        <p:nvSpPr>
-          <p:cNvPr id="15" name="Step 2"/>
-          <p:cNvSpPr txBox="1"/>
-          <p:nvPr/>
-        </p:nvSpPr>
-        <p:spPr>
-          <a:xfrm>
-            <a:off x="5348326" y="3858768"/>
-            <a:ext cx="2530602" cy="585216"/>
-          </a:xfrm>
-          <a:prstGeom prst="rect">
-            <a:avLst/>
-          </a:prstGeom>
-          <a:noFill/>
-          <a:ln/>
-        </p:spPr>
-        <p:txBody>
-          <a:bodyPr wrap="square" lIns="0" tIns="0" rIns="0" bIns="0" rtlCol="0" anchor="t"/>
-          <a:lstStyle/>
-          <a:p>
-            <a:pPr indent="0" marL="0">
-              <a:buNone/>
-            </a:pPr>
-            <a:r>
-              <a:rPr lang="en-US" sz="1300" b="1" dirty="0">
-                <a:solidFill>
-                  <a:schemeClr val="bg1"/>
-                </a:solidFill>
-              </a:rPr>
-              <a:t>Collect</a:t>
-            </a:r>
-            <a:pPr indent="0" marL="0">
-              <a:buNone/>
-            </a:pPr>
-            <a:r>
-              <a:rPr lang="en-US" sz="1300" dirty="0">
-                <a:solidFill>
-                  <a:schemeClr val="accent4"/>
-                </a:solidFill>
-              </a:rPr>
-              <a:t>: Collector on the VM, read-only AWS integration</a:t>
-            </a:r>
-            <a:endParaRPr lang="en-US" sz="1300" dirty="0"/>
-          </a:p>
-        </p:txBody>
-      </p:sp>
-      <p:sp>
-        <p:nvSpPr>
-          <p:cNvPr id="16" name="Step 3 badge"/>
-          <p:cNvSpPr/>
-          <p:nvPr/>
-        </p:nvSpPr>
-        <p:spPr>
-          <a:xfrm>
-            <a:off x="4927702" y="4535424"/>
-            <a:ext cx="310896" cy="310896"/>
-          </a:xfrm>
-          <a:prstGeom prst="ellipse">
-            <a:avLst/>
-          </a:prstGeom>
-          <a:solidFill>
-            <a:schemeClr val="accent1"/>
-          </a:solidFill>
-          <a:ln/>
-        </p:spPr>
-      </p:sp>
-      <p:sp>
-        <p:nvSpPr>
-          <p:cNvPr id="17" name="Step 3 number"/>
-          <p:cNvSpPr txBox="1"/>
-          <p:nvPr/>
-        </p:nvSpPr>
-        <p:spPr>
-          <a:xfrm>
-            <a:off x="4927702" y="4535424"/>
-            <a:ext cx="310896" cy="310896"/>
-          </a:xfrm>
-          <a:prstGeom prst="rect">
-            <a:avLst/>
-          </a:prstGeom>
-          <a:noFill/>
-          <a:ln/>
-        </p:spPr>
-        <p:txBody>
-          <a:bodyPr wrap="square" lIns="0" tIns="0" rIns="0" bIns="0" rtlCol="0" anchor="ctr"/>
-          <a:lstStyle/>
-          <a:p>
-            <a:pPr algn="ctr" indent="0" marL="0">
-              <a:buNone/>
-            </a:pPr>
-            <a:r>
-              <a:rPr lang="en-US" sz="1200" b="1" dirty="0">
-                <a:solidFill>
-                  <a:schemeClr val="tx1"/>
-                </a:solidFill>
-              </a:rPr>
-              <a:t>3</a:t>
-            </a:r>
-            <a:endParaRPr lang="en-US" sz="1200" dirty="0"/>
-          </a:p>
-        </p:txBody>
-      </p:sp>
-      <p:sp>
-        <p:nvSpPr>
-          <p:cNvPr id="18" name="Step 3"/>
-          <p:cNvSpPr txBox="1"/>
-          <p:nvPr/>
-        </p:nvSpPr>
-        <p:spPr>
-          <a:xfrm>
-            <a:off x="5348326" y="4517136"/>
-            <a:ext cx="2530602" cy="585216"/>
-          </a:xfrm>
-          <a:prstGeom prst="rect">
-            <a:avLst/>
-          </a:prstGeom>
-          <a:noFill/>
-          <a:ln/>
-        </p:spPr>
-        <p:txBody>
-          <a:bodyPr wrap="square" lIns="0" tIns="0" rIns="0" bIns="0" rtlCol="0" anchor="t"/>
-          <a:lstStyle/>
-          <a:p>
-            <a:pPr indent="0" marL="0">
-              <a:buNone/>
-            </a:pPr>
-            <a:r>
-              <a:rPr lang="en-US" sz="1300" b="1" dirty="0">
-                <a:solidFill>
-                  <a:schemeClr val="bg1"/>
-                </a:solidFill>
-              </a:rPr>
-              <a:t>Discover</a:t>
-            </a:r>
-            <a:pPr indent="0" marL="0">
-              <a:buNone/>
-            </a:pPr>
-            <a:r>
-              <a:rPr lang="en-US" sz="1300" dirty="0">
-                <a:solidFill>
-                  <a:schemeClr val="accent4"/>
-                </a:solidFill>
-              </a:rPr>
-              <a:t>: properties apply SNMP, SSH and JMX modules</a:t>
-            </a:r>
-            <a:endParaRPr lang="en-US" sz="1300" dirty="0"/>
-          </a:p>
-        </p:txBody>
-      </p:sp>
-      <p:sp>
-        <p:nvSpPr>
-          <p:cNvPr id="19" name="Step 4 badge"/>
-          <p:cNvSpPr/>
-          <p:nvPr/>
-        </p:nvSpPr>
-        <p:spPr>
-          <a:xfrm>
-            <a:off x="4927702" y="5193792"/>
-            <a:ext cx="310896" cy="310896"/>
-          </a:xfrm>
-          <a:prstGeom prst="ellipse">
-            <a:avLst/>
-          </a:prstGeom>
-          <a:solidFill>
-            <a:schemeClr val="accent1"/>
-          </a:solidFill>
-          <a:ln/>
-        </p:spPr>
-      </p:sp>
-      <p:sp>
-        <p:nvSpPr>
-          <p:cNvPr id="20" name="Step 4 number"/>
-          <p:cNvSpPr txBox="1"/>
-          <p:nvPr/>
-        </p:nvSpPr>
-        <p:spPr>
-          <a:xfrm>
-            <a:off x="4927702" y="5193792"/>
-            <a:ext cx="310896" cy="310896"/>
-          </a:xfrm>
-          <a:prstGeom prst="rect">
-            <a:avLst/>
-          </a:prstGeom>
-          <a:noFill/>
-          <a:ln/>
-        </p:spPr>
-        <p:txBody>
-          <a:bodyPr wrap="square" lIns="0" tIns="0" rIns="0" bIns="0" rtlCol="0" anchor="ctr"/>
-          <a:lstStyle/>
-          <a:p>
-            <a:pPr algn="ctr" indent="0" marL="0">
-              <a:buNone/>
-            </a:pPr>
-            <a:r>
-              <a:rPr lang="en-US" sz="1200" b="1" dirty="0">
-                <a:solidFill>
-                  <a:schemeClr val="tx1"/>
-                </a:solidFill>
-              </a:rPr>
-              <a:t>4</a:t>
-            </a:r>
-            <a:endParaRPr lang="en-US" sz="1200" dirty="0"/>
-          </a:p>
-        </p:txBody>
-      </p:sp>
-      <p:sp>
-        <p:nvSpPr>
-          <p:cNvPr id="21" name="Step 4"/>
-          <p:cNvSpPr txBox="1"/>
-          <p:nvPr/>
-        </p:nvSpPr>
-        <p:spPr>
-          <a:xfrm>
-            <a:off x="5348326" y="5175504"/>
-            <a:ext cx="2530602" cy="585216"/>
-          </a:xfrm>
-          <a:prstGeom prst="rect">
-            <a:avLst/>
-          </a:prstGeom>
-          <a:noFill/>
-          <a:ln/>
-        </p:spPr>
-        <p:txBody>
-          <a:bodyPr wrap="square" lIns="0" tIns="0" rIns="0" bIns="0" rtlCol="0" anchor="t"/>
-          <a:lstStyle/>
-          <a:p>
-            <a:pPr indent="0" marL="0">
-              <a:buNone/>
-            </a:pPr>
-            <a:r>
-              <a:rPr lang="en-US" sz="1300" b="1" dirty="0">
-                <a:solidFill>
-                  <a:schemeClr val="bg1"/>
-                </a:solidFill>
-              </a:rPr>
-              <a:t>Instrument</a:t>
-            </a:r>
-            <a:pPr indent="0" marL="0">
-              <a:buNone/>
-            </a:pPr>
-            <a:r>
-              <a:rPr lang="en-US" sz="1300" dirty="0">
-                <a:solidFill>
-                  <a:schemeClr val="accent4"/>
-                </a:solidFill>
-              </a:rPr>
-              <a:t>: Groovy DataSource with technical and business KPIs</a:t>
-            </a:r>
-            <a:endParaRPr lang="en-US" sz="1300" dirty="0"/>
-          </a:p>
-        </p:txBody>
-      </p:sp>
-      <p:sp>
-        <p:nvSpPr>
-          <p:cNvPr id="22" name="Step 5 badge"/>
-          <p:cNvSpPr/>
-          <p:nvPr/>
-        </p:nvSpPr>
-        <p:spPr>
-          <a:xfrm>
-            <a:off x="8153248" y="3218688"/>
-            <a:ext cx="310896" cy="310896"/>
-          </a:xfrm>
-          <a:prstGeom prst="ellipse">
-            <a:avLst/>
-          </a:prstGeom>
-          <a:solidFill>
-            <a:schemeClr val="accent1"/>
-          </a:solidFill>
-          <a:ln/>
-        </p:spPr>
-      </p:sp>
-      <p:sp>
-        <p:nvSpPr>
-          <p:cNvPr id="23" name="Step 5 number"/>
-          <p:cNvSpPr txBox="1"/>
-          <p:nvPr/>
-        </p:nvSpPr>
-        <p:spPr>
-          <a:xfrm>
-            <a:off x="8153248" y="3218688"/>
-            <a:ext cx="310896" cy="310896"/>
-          </a:xfrm>
-          <a:prstGeom prst="rect">
-            <a:avLst/>
-          </a:prstGeom>
-          <a:noFill/>
-          <a:ln/>
-        </p:spPr>
-        <p:txBody>
-          <a:bodyPr wrap="square" lIns="0" tIns="0" rIns="0" bIns="0" rtlCol="0" anchor="ctr"/>
-          <a:lstStyle/>
-          <a:p>
-            <a:pPr algn="ctr" indent="0" marL="0">
-              <a:buNone/>
-            </a:pPr>
-            <a:r>
-              <a:rPr lang="en-US" sz="1200" b="1" dirty="0">
-                <a:solidFill>
-                  <a:schemeClr val="tx1"/>
-                </a:solidFill>
-              </a:rPr>
-              <a:t>5</a:t>
-            </a:r>
-            <a:endParaRPr lang="en-US" sz="1200" dirty="0"/>
-          </a:p>
-        </p:txBody>
-      </p:sp>
-      <p:sp>
-        <p:nvSpPr>
-          <p:cNvPr id="24" name="Step 5"/>
-          <p:cNvSpPr txBox="1"/>
-          <p:nvPr/>
-        </p:nvSpPr>
-        <p:spPr>
-          <a:xfrm>
-            <a:off x="8573872" y="3200400"/>
-            <a:ext cx="2530602" cy="585216"/>
-          </a:xfrm>
-          <a:prstGeom prst="rect">
-            <a:avLst/>
-          </a:prstGeom>
-          <a:noFill/>
-          <a:ln/>
-        </p:spPr>
-        <p:txBody>
-          <a:bodyPr wrap="square" lIns="0" tIns="0" rIns="0" bIns="0" rtlCol="0" anchor="t"/>
-          <a:lstStyle/>
-          <a:p>
-            <a:pPr indent="0" marL="0">
-              <a:buNone/>
-            </a:pPr>
-            <a:r>
-              <a:rPr lang="en-US" sz="1300" b="1" dirty="0">
-                <a:solidFill>
-                  <a:schemeClr val="bg1"/>
-                </a:solidFill>
-              </a:rPr>
-              <a:t>Test outside-in</a:t>
-            </a:r>
-            <a:pPr indent="0" marL="0">
-              <a:buNone/>
-            </a:pPr>
-            <a:r>
-              <a:rPr lang="en-US" sz="1300" dirty="0">
-                <a:solidFill>
-                  <a:schemeClr val="accent4"/>
-                </a:solidFill>
-              </a:rPr>
-              <a:t> with an LM Uptime check that files a report</a:t>
-            </a:r>
-            <a:endParaRPr lang="en-US" sz="1300" dirty="0"/>
-          </a:p>
-        </p:txBody>
-      </p:sp>
-      <p:sp>
-        <p:nvSpPr>
-          <p:cNvPr id="25" name="Step 6 badge"/>
-          <p:cNvSpPr/>
-          <p:nvPr/>
-        </p:nvSpPr>
-        <p:spPr>
-          <a:xfrm>
-            <a:off x="8153248" y="3877056"/>
-            <a:ext cx="310896" cy="310896"/>
-          </a:xfrm>
-          <a:prstGeom prst="ellipse">
-            <a:avLst/>
-          </a:prstGeom>
-          <a:solidFill>
-            <a:schemeClr val="accent1"/>
-          </a:solidFill>
-          <a:ln/>
-        </p:spPr>
-      </p:sp>
-      <p:sp>
-        <p:nvSpPr>
-          <p:cNvPr id="26" name="Step 6 number"/>
-          <p:cNvSpPr txBox="1"/>
-          <p:nvPr/>
-        </p:nvSpPr>
-        <p:spPr>
-          <a:xfrm>
-            <a:off x="8153248" y="3877056"/>
-            <a:ext cx="310896" cy="310896"/>
-          </a:xfrm>
-          <a:prstGeom prst="rect">
-            <a:avLst/>
-          </a:prstGeom>
-          <a:noFill/>
-          <a:ln/>
-        </p:spPr>
-        <p:txBody>
-          <a:bodyPr wrap="square" lIns="0" tIns="0" rIns="0" bIns="0" rtlCol="0" anchor="ctr"/>
-          <a:lstStyle/>
-          <a:p>
-            <a:pPr algn="ctr" indent="0" marL="0">
-              <a:buNone/>
-            </a:pPr>
-            <a:r>
-              <a:rPr lang="en-US" sz="1200" b="1" dirty="0">
-                <a:solidFill>
-                  <a:schemeClr val="tx1"/>
-                </a:solidFill>
-              </a:rPr>
-              <a:t>6</a:t>
-            </a:r>
-            <a:endParaRPr lang="en-US" sz="1200" dirty="0"/>
-          </a:p>
-        </p:txBody>
-      </p:sp>
-      <p:sp>
-        <p:nvSpPr>
-          <p:cNvPr id="27" name="Step 6"/>
-          <p:cNvSpPr txBox="1"/>
-          <p:nvPr/>
-        </p:nvSpPr>
-        <p:spPr>
-          <a:xfrm>
-            <a:off x="8573872" y="3858768"/>
-            <a:ext cx="2530602" cy="585216"/>
-          </a:xfrm>
-          <a:prstGeom prst="rect">
-            <a:avLst/>
-          </a:prstGeom>
-          <a:noFill/>
-          <a:ln/>
-        </p:spPr>
-        <p:txBody>
-          <a:bodyPr wrap="square" lIns="0" tIns="0" rIns="0" bIns="0" rtlCol="0" anchor="t"/>
-          <a:lstStyle/>
-          <a:p>
-            <a:pPr indent="0" marL="0">
-              <a:buNone/>
-            </a:pPr>
-            <a:r>
-              <a:rPr lang="en-US" sz="1300" b="1" dirty="0">
-                <a:solidFill>
-                  <a:schemeClr val="bg1"/>
-                </a:solidFill>
-              </a:rPr>
-              <a:t>Correlate</a:t>
-            </a:r>
-            <a:pPr indent="0" marL="0">
-              <a:buNone/>
-            </a:pPr>
-            <a:r>
-              <a:rPr lang="en-US" sz="1300" dirty="0">
-                <a:solidFill>
-                  <a:schemeClr val="accent4"/>
-                </a:solidFill>
-              </a:rPr>
-              <a:t> with LM Logs on the same resource</a:t>
-            </a:r>
-            <a:endParaRPr lang="en-US" sz="1300" dirty="0"/>
-          </a:p>
-        </p:txBody>
-      </p:sp>
-      <p:sp>
-        <p:nvSpPr>
-          <p:cNvPr id="28" name="Step 7 badge"/>
-          <p:cNvSpPr/>
-          <p:nvPr/>
-        </p:nvSpPr>
-        <p:spPr>
-          <a:xfrm>
-            <a:off x="8153248" y="4535424"/>
-            <a:ext cx="310896" cy="310896"/>
-          </a:xfrm>
-          <a:prstGeom prst="ellipse">
-            <a:avLst/>
-          </a:prstGeom>
-          <a:solidFill>
-            <a:schemeClr val="accent1"/>
-          </a:solidFill>
-          <a:ln/>
-        </p:spPr>
-      </p:sp>
-      <p:sp>
-        <p:nvSpPr>
-          <p:cNvPr id="29" name="Step 7 number"/>
-          <p:cNvSpPr txBox="1"/>
-          <p:nvPr/>
-        </p:nvSpPr>
-        <p:spPr>
-          <a:xfrm>
-            <a:off x="8153248" y="4535424"/>
-            <a:ext cx="310896" cy="310896"/>
-          </a:xfrm>
-          <a:prstGeom prst="rect">
-            <a:avLst/>
-          </a:prstGeom>
-          <a:noFill/>
-          <a:ln/>
-        </p:spPr>
-        <p:txBody>
-          <a:bodyPr wrap="square" lIns="0" tIns="0" rIns="0" bIns="0" rtlCol="0" anchor="ctr"/>
-          <a:lstStyle/>
-          <a:p>
-            <a:pPr algn="ctr" indent="0" marL="0">
-              <a:buNone/>
-            </a:pPr>
-            <a:r>
-              <a:rPr lang="en-US" sz="1200" b="1" dirty="0">
-                <a:solidFill>
-                  <a:schemeClr val="tx1"/>
-                </a:solidFill>
-              </a:rPr>
-              <a:t>7</a:t>
-            </a:r>
-            <a:endParaRPr lang="en-US" sz="1200" dirty="0"/>
-          </a:p>
-        </p:txBody>
-      </p:sp>
-      <p:sp>
-        <p:nvSpPr>
-          <p:cNvPr id="30" name="Step 7"/>
-          <p:cNvSpPr txBox="1"/>
-          <p:nvPr/>
-        </p:nvSpPr>
-        <p:spPr>
-          <a:xfrm>
-            <a:off x="8573872" y="4517136"/>
-            <a:ext cx="2530602" cy="585216"/>
-          </a:xfrm>
-          <a:prstGeom prst="rect">
-            <a:avLst/>
-          </a:prstGeom>
-          <a:noFill/>
-          <a:ln/>
-        </p:spPr>
-        <p:txBody>
-          <a:bodyPr wrap="square" lIns="0" tIns="0" rIns="0" bIns="0" rtlCol="0" anchor="t"/>
-          <a:lstStyle/>
-          <a:p>
-            <a:pPr indent="0" marL="0">
-              <a:buNone/>
-            </a:pPr>
-            <a:r>
-              <a:rPr lang="en-US" sz="1300" b="1" dirty="0">
-                <a:solidFill>
-                  <a:schemeClr val="bg1"/>
-                </a:solidFill>
-              </a:rPr>
-              <a:t>Act</a:t>
-            </a:r>
-            <a:pPr indent="0" marL="0">
-              <a:buNone/>
-            </a:pPr>
-            <a:r>
-              <a:rPr lang="en-US" sz="1300" dirty="0">
-                <a:solidFill>
-                  <a:schemeClr val="accent4"/>
-                </a:solidFill>
-              </a:rPr>
-              <a:t>: alert rule, escalation chain, dashboard</a:t>
-            </a:r>
-            <a:endParaRPr lang="en-US" sz="1300" dirty="0"/>
-          </a:p>
-        </p:txBody>
-      </p:sp>
-      <p:sp>
-        <p:nvSpPr>
-          <p:cNvPr id="31" name="Step 8 badge"/>
-          <p:cNvSpPr/>
-          <p:nvPr/>
-        </p:nvSpPr>
-        <p:spPr>
-          <a:xfrm>
-            <a:off x="8153248" y="5193792"/>
-            <a:ext cx="310896" cy="310896"/>
-          </a:xfrm>
-          <a:prstGeom prst="ellipse">
-            <a:avLst/>
-          </a:prstGeom>
-          <a:solidFill>
-            <a:schemeClr val="accent1"/>
-          </a:solidFill>
-          <a:ln/>
-        </p:spPr>
-      </p:sp>
-      <p:sp>
-        <p:nvSpPr>
-          <p:cNvPr id="32" name="Step 8 number"/>
-          <p:cNvSpPr txBox="1"/>
-          <p:nvPr/>
-        </p:nvSpPr>
-        <p:spPr>
-          <a:xfrm>
-            <a:off x="8153248" y="5193792"/>
-            <a:ext cx="310896" cy="310896"/>
-          </a:xfrm>
-          <a:prstGeom prst="rect">
-            <a:avLst/>
-          </a:prstGeom>
-          <a:noFill/>
-          <a:ln/>
-        </p:spPr>
-        <p:txBody>
-          <a:bodyPr wrap="square" lIns="0" tIns="0" rIns="0" bIns="0" rtlCol="0" anchor="ctr"/>
-          <a:lstStyle/>
-          <a:p>
-            <a:pPr algn="ctr" indent="0" marL="0">
-              <a:buNone/>
-            </a:pPr>
-            <a:r>
-              <a:rPr lang="en-US" sz="1200" b="1" dirty="0">
-                <a:solidFill>
-                  <a:schemeClr val="tx1"/>
-                </a:solidFill>
-              </a:rPr>
-              <a:t>8</a:t>
-            </a:r>
-            <a:endParaRPr lang="en-US" sz="1200" dirty="0"/>
-          </a:p>
-        </p:txBody>
-      </p:sp>
-      <p:sp>
-        <p:nvSpPr>
-          <p:cNvPr id="33" name="Step 8"/>
-          <p:cNvSpPr txBox="1"/>
-          <p:nvPr/>
-        </p:nvSpPr>
-        <p:spPr>
-          <a:xfrm>
-            <a:off x="8573872" y="5175504"/>
-            <a:ext cx="2530602" cy="585216"/>
-          </a:xfrm>
-          <a:prstGeom prst="rect">
-            <a:avLst/>
-          </a:prstGeom>
-          <a:noFill/>
-          <a:ln/>
-        </p:spPr>
-        <p:txBody>
-          <a:bodyPr wrap="square" lIns="0" tIns="0" rIns="0" bIns="0" rtlCol="0" anchor="t"/>
-          <a:lstStyle/>
-          <a:p>
-            <a:pPr indent="0" marL="0">
-              <a:buNone/>
-            </a:pPr>
-            <a:r>
-              <a:rPr lang="en-US" sz="1300" b="1" dirty="0">
-                <a:solidFill>
-                  <a:schemeClr val="bg1"/>
-                </a:solidFill>
-              </a:rPr>
-              <a:t>Prove</a:t>
-            </a:r>
-            <a:pPr indent="0" marL="0">
-              <a:buNone/>
-            </a:pPr>
-            <a:r>
-              <a:rPr lang="en-US" sz="1300" dirty="0">
-                <a:solidFill>
-                  <a:schemeClr val="accent4"/>
-                </a:solidFill>
-              </a:rPr>
-              <a:t> it: break and fix, one alert per cause</a:t>
+                  <a:schemeClr val="tx2"/>
+                </a:solidFill>
+              </a:rPr>
+              <a:t>Deployed from code · Collector and read-only AWS role · SNMP, JMX and a Groovy DataSource · web check from 5 locations · LM Logs · alert routing</a:t>
             </a:r>
             <a:endParaRPr lang="en-US" sz="1300" dirty="0"/>
           </a:p>

</xml_diff>